<commit_message>
Add LLM reranker, fix photo-context memory loss across turns, add presentation decks
The reranker (factory_floor/rag.py) fetches a wider candidate pool from Chroma
and reorders it with one LLM call before narrowing back to top-k — addressing
the documented weakness of pure embedding search on exact alphanumeric fault
codes (dificuldades_e_oportunidades.md, difficulty #1). Opt-in via
build_retriever(..., rerank=True); every existing caller keeps prior behavior.

Photo-context memory fix: build_chat_history() now replays a turn's
vision_context alongside its question, and app.py stores it on the turn. Before
this, a follow-up question after a photo lost all memory of the classification
and asked the operator to upload the photo again.

Co-Authored-By: Claude Sonnet 5 <noreply@anthropic.com>
Claude-Session: https://claude.ai/code/session_011iVgkFb4vk7QSuG3Z7ovqV
</commit_message>
<xml_diff>
--- a/vertical_slice_slide.pptx
+++ b/vertical_slice_slide.pptx
@@ -3140,7 +3140,7 @@
         </p:nvSpPr>
         <p:spPr>
           <a:xfrm>
-            <a:off x="457200" y="274320"/>
+            <a:off x="457200" y="256032"/>
             <a:ext cx="11247120" cy="548640"/>
           </a:xfrm>
           <a:prstGeom prst="rect">
@@ -3160,7 +3160,7 @@
               </a:spcAft>
             </a:pPr>
             <a:r>
-              <a:rPr sz="2600" b="1" i="0">
+              <a:rPr sz="2500" b="1" i="0">
                 <a:solidFill>
                   <a:srgbClr val="1F2A33"/>
                 </a:solidFill>
@@ -3179,7 +3179,7 @@
         </p:nvSpPr>
         <p:spPr>
           <a:xfrm>
-            <a:off x="457200" y="822960"/>
+            <a:off x="457200" y="777240"/>
             <a:ext cx="11247120" cy="365760"/>
           </a:xfrm>
           <a:prstGeom prst="rect">
@@ -3199,13 +3199,13 @@
               </a:spcAft>
             </a:pPr>
             <a:r>
-              <a:rPr sz="1300" b="0" i="0">
+              <a:rPr sz="1250" b="0" i="0">
                 <a:solidFill>
                   <a:srgbClr val="5B6168"/>
                 </a:solidFill>
                 <a:latin typeface="Calibri"/>
               </a:rPr>
-              <a:t>No fault code involved — a real conflict between what the operator says and what the photo shows, traced through the whole system.</a:t>
+              <a:t>A realistic operator report, verified live through vision, retrieval, and the agent — a complete answer, not a fragment.</a:t>
             </a:r>
           </a:p>
         </p:txBody>
@@ -3218,12 +3218,12 @@
         </p:nvSpPr>
         <p:spPr>
           <a:xfrm>
-            <a:off x="411480" y="1554480"/>
-            <a:ext cx="2331720" cy="2331720"/>
+            <a:off x="365760" y="1417320"/>
+            <a:ext cx="1783080" cy="2697480"/>
           </a:xfrm>
           <a:prstGeom prst="roundRect">
             <a:avLst>
-              <a:gd name="adj" fmla="val 6000"/>
+              <a:gd name="adj" fmla="val 5000"/>
             </a:avLst>
           </a:prstGeom>
           <a:solidFill>
@@ -3249,7 +3249,7 @@
           </a:fontRef>
         </p:style>
         <p:txBody>
-          <a:bodyPr rtlCol="0" anchor="t" wrap="square" lIns="164592" rIns="164592" tIns="109728" bIns="109728"/>
+          <a:bodyPr rtlCol="0" anchor="t" wrap="square" lIns="146304" rIns="146304" tIns="109728" bIns="109728"/>
           <a:lstStyle/>
           <a:p>
             <a:pPr algn="l">
@@ -3258,7 +3258,7 @@
               </a:spcAft>
             </a:pPr>
             <a:r>
-              <a:rPr sz="1100" b="1" i="0">
+              <a:rPr sz="1050" b="1" i="0">
                 <a:solidFill>
                   <a:srgbClr val="5B6168"/>
                 </a:solidFill>
@@ -3274,13 +3274,13 @@
               </a:spcAft>
             </a:pPr>
             <a:r>
-              <a:rPr sz="1200" b="1" i="0">
+              <a:rPr sz="1150" b="1" i="0">
                 <a:solidFill>
                   <a:srgbClr val="1F2A33"/>
                 </a:solidFill>
                 <a:latin typeface="Calibri"/>
               </a:rPr>
-              <a:t>Photo of a component +</a:t>
+              <a:t>Photo of a damaged part +</a:t>
             </a:r>
           </a:p>
           <a:p>
@@ -3290,13 +3290,13 @@
               </a:spcAft>
             </a:pPr>
             <a:r>
-              <a:rPr sz="1200" b="1" i="0">
+              <a:rPr sz="1150" b="1" i="0">
                 <a:solidFill>
                   <a:srgbClr val="1F2A33"/>
                 </a:solidFill>
                 <a:latin typeface="Calibri"/>
               </a:rPr>
-              <a:t>"Just a tiny cosmetic scuff,</a:t>
+              <a:t>"Found this damaged</a:t>
             </a:r>
           </a:p>
           <a:p>
@@ -3306,13 +3306,45 @@
               </a:spcAft>
             </a:pPr>
             <a:r>
-              <a:rPr sz="1200" b="1" i="0">
+              <a:rPr sz="1150" b="1" i="0">
                 <a:solidFill>
                   <a:srgbClr val="1F2A33"/>
                 </a:solidFill>
                 <a:latin typeface="Calibri"/>
               </a:rPr>
-              <a:t>nothing serious, probably fine</a:t>
+              <a:t>component on VFD-06 during</a:t>
+            </a:r>
+          </a:p>
+          <a:p>
+            <a:pPr algn="l">
+              <a:spcAft>
+                <a:spcPts val="100"/>
+              </a:spcAft>
+            </a:pPr>
+            <a:r>
+              <a:rPr sz="1150" b="1" i="0">
+                <a:solidFill>
+                  <a:srgbClr val="1F2A33"/>
+                </a:solidFill>
+                <a:latin typeface="Calibri"/>
+              </a:rPr>
+              <a:t>a routine inspection. What</a:t>
+            </a:r>
+          </a:p>
+          <a:p>
+            <a:pPr algn="l">
+              <a:spcAft>
+                <a:spcPts val="100"/>
+              </a:spcAft>
+            </a:pPr>
+            <a:r>
+              <a:rPr sz="1150" b="1" i="0">
+                <a:solidFill>
+                  <a:srgbClr val="1F2A33"/>
+                </a:solidFill>
+                <a:latin typeface="Calibri"/>
+              </a:rPr>
+              <a:t>should be checked before</a:t>
             </a:r>
           </a:p>
           <a:p>
@@ -3322,13 +3354,13 @@
               </a:spcAft>
             </a:pPr>
             <a:r>
-              <a:rPr sz="1200" b="1" i="0">
+              <a:rPr sz="1150" b="1" i="0">
                 <a:solidFill>
                   <a:srgbClr val="1F2A33"/>
                 </a:solidFill>
                 <a:latin typeface="Calibri"/>
               </a:rPr>
-              <a:t>to keep running."</a:t>
+              <a:t>replacing it?"</a:t>
             </a:r>
           </a:p>
           <a:p>
@@ -3338,7 +3370,7 @@
               </a:spcAft>
             </a:pPr>
             <a:r>
-              <a:rPr sz="1000" b="0" i="0">
+              <a:rPr sz="950" b="0" i="0">
                 <a:solidFill>
                   <a:srgbClr val="5B6168"/>
                 </a:solidFill>
@@ -3357,12 +3389,12 @@
         </p:nvSpPr>
         <p:spPr>
           <a:xfrm>
-            <a:off x="2971800" y="1554480"/>
-            <a:ext cx="2331720" cy="2331720"/>
+            <a:off x="2423160" y="1417320"/>
+            <a:ext cx="1783080" cy="2697480"/>
           </a:xfrm>
           <a:prstGeom prst="roundRect">
             <a:avLst>
-              <a:gd name="adj" fmla="val 6000"/>
+              <a:gd name="adj" fmla="val 5000"/>
             </a:avLst>
           </a:prstGeom>
           <a:solidFill>
@@ -3388,12 +3420,12 @@
           </a:fontRef>
         </p:style>
         <p:txBody>
-          <a:bodyPr rtlCol="0" anchor="t" wrap="square" lIns="164592" rIns="164592" tIns="109728" bIns="109728"/>
+          <a:bodyPr rtlCol="0" anchor="t" wrap="square" lIns="146304" rIns="146304" tIns="109728" bIns="109728"/>
           <a:lstStyle/>
           <a:p>
             <a:pPr algn="l">
               <a:spcAft>
-                <a:spcPts val="600"/>
+                <a:spcPts val="500"/>
               </a:spcAft>
             </a:pPr>
             <a:r>
@@ -3403,7 +3435,7 @@
                 </a:solidFill>
                 <a:latin typeface="Calibri"/>
               </a:rPr>
-              <a:t>VISION TOOL — REAL, NOT SIMULATED</a:t>
+              <a:t>VISION TOOL</a:t>
             </a:r>
           </a:p>
           <a:p>
@@ -3413,13 +3445,13 @@
               </a:spcAft>
             </a:pPr>
             <a:r>
-              <a:rPr sz="1150" b="1" i="0">
+              <a:rPr sz="1050" b="1" i="0">
                 <a:solidFill>
                   <a:srgbClr val="FFFFFF"/>
                 </a:solidFill>
                 <a:latin typeface="Calibri"/>
               </a:rPr>
-              <a:t>classify_defect_trained(photo)</a:t>
+              <a:t>classify_defect_trained</a:t>
             </a:r>
           </a:p>
           <a:p>
@@ -3429,13 +3461,45 @@
               </a:spcAft>
             </a:pPr>
             <a:r>
-              <a:rPr sz="1300" b="1" i="0">
+              <a:rPr sz="1250" b="1" i="0">
                 <a:solidFill>
                   <a:srgbClr val="FFFFFF"/>
                 </a:solidFill>
                 <a:latin typeface="Calibri"/>
               </a:rPr>
               <a:t>→ structural_damage</a:t>
+            </a:r>
+          </a:p>
+          <a:p>
+            <a:pPr algn="l">
+              <a:spcAft>
+                <a:spcPts val="400"/>
+              </a:spcAft>
+            </a:pPr>
+            <a:r>
+              <a:rPr sz="1050" b="0" i="0">
+                <a:solidFill>
+                  <a:srgbClr val="E4F2EC"/>
+                </a:solidFill>
+                <a:latin typeface="Calibri"/>
+              </a:rPr>
+              <a:t>(96% confidence)</a:t>
+            </a:r>
+          </a:p>
+          <a:p>
+            <a:pPr algn="l">
+              <a:spcAft>
+                <a:spcPts val="100"/>
+              </a:spcAft>
+            </a:pPr>
+            <a:r>
+              <a:rPr sz="950" b="0" i="0">
+                <a:solidFill>
+                  <a:srgbClr val="E4F2EC"/>
+                </a:solidFill>
+                <a:latin typeface="Calibri"/>
+              </a:rPr>
+              <a:t>Agrees with the operator's</a:t>
             </a:r>
           </a:p>
           <a:p>
@@ -3445,13 +3509,13 @@
               </a:spcAft>
             </a:pPr>
             <a:r>
-              <a:rPr sz="1100" b="0" i="0">
+              <a:rPr sz="950" b="0" i="0">
                 <a:solidFill>
                   <a:srgbClr val="E4F2EC"/>
                 </a:solidFill>
                 <a:latin typeface="Calibri"/>
               </a:rPr>
-              <a:t>(82% confidence)</a:t>
+              <a:t>own description — no conflict</a:t>
             </a:r>
           </a:p>
         </p:txBody>
@@ -3464,12 +3528,12 @@
         </p:nvSpPr>
         <p:spPr>
           <a:xfrm>
-            <a:off x="5532120" y="1554480"/>
-            <a:ext cx="2606040" cy="2331720"/>
+            <a:off x="4480560" y="1417320"/>
+            <a:ext cx="1783080" cy="2697480"/>
           </a:xfrm>
           <a:prstGeom prst="roundRect">
             <a:avLst>
-              <a:gd name="adj" fmla="val 6000"/>
+              <a:gd name="adj" fmla="val 5000"/>
             </a:avLst>
           </a:prstGeom>
           <a:solidFill>
@@ -3495,7 +3559,7 @@
           </a:fontRef>
         </p:style>
         <p:txBody>
-          <a:bodyPr rtlCol="0" anchor="t" wrap="square" lIns="164592" rIns="164592" tIns="109728" bIns="109728"/>
+          <a:bodyPr rtlCol="0" anchor="t" wrap="square" lIns="146304" rIns="146304" tIns="109728" bIns="109728"/>
           <a:lstStyle/>
           <a:p>
             <a:pPr algn="l">
@@ -3504,29 +3568,13 @@
               </a:spcAft>
             </a:pPr>
             <a:r>
-              <a:rPr sz="1100" b="1" i="0">
+              <a:rPr sz="1050" b="1" i="0">
                 <a:solidFill>
                   <a:srgbClr val="C7CDD3"/>
                 </a:solidFill>
                 <a:latin typeface="Calibri"/>
               </a:rPr>
               <a:t>AGENT DECIDES</a:t>
-            </a:r>
-          </a:p>
-          <a:p>
-            <a:pPr algn="l">
-              <a:spcAft>
-                <a:spcPts val="300"/>
-              </a:spcAft>
-            </a:pPr>
-            <a:r>
-              <a:rPr sz="1250" b="1" i="0">
-                <a:solidFill>
-                  <a:srgbClr val="FFFFFF"/>
-                </a:solidFill>
-                <a:latin typeface="Calibri"/>
-              </a:rPr>
-              <a:t>Detects a real conflict:</a:t>
             </a:r>
           </a:p>
           <a:p>
@@ -3536,13 +3584,29 @@
               </a:spcAft>
             </a:pPr>
             <a:r>
-              <a:rPr sz="1100" b="0" i="0">
-                <a:solidFill>
-                  <a:srgbClr val="C7CDD3"/>
+              <a:rPr sz="1150" b="1" i="0">
+                <a:solidFill>
+                  <a:srgbClr val="FFFFFF"/>
                 </a:solidFill>
                 <a:latin typeface="Calibri"/>
               </a:rPr>
-              <a:t>text says "minor" — vision says</a:t>
+              <a:t>Signals agree —</a:t>
+            </a:r>
+          </a:p>
+          <a:p>
+            <a:pPr algn="l">
+              <a:spcAft>
+                <a:spcPts val="100"/>
+              </a:spcAft>
+            </a:pPr>
+            <a:r>
+              <a:rPr sz="1050" b="0" i="0">
+                <a:solidFill>
+                  <a:srgbClr val="C7CDD3"/>
+                </a:solidFill>
+                <a:latin typeface="Calibri"/>
+              </a:rPr>
+              <a:t>needs grounded evidence,</a:t>
             </a:r>
           </a:p>
           <a:p>
@@ -3552,13 +3616,13 @@
               </a:spcAft>
             </a:pPr>
             <a:r>
-              <a:rPr sz="1100" b="0" i="0">
+              <a:rPr sz="1050" b="0" i="0">
                 <a:solidFill>
                   <a:srgbClr val="C7CDD3"/>
                 </a:solidFill>
                 <a:latin typeface="Calibri"/>
               </a:rPr>
-              <a:t>structural damage, high confidence</a:t>
+              <a:t>not general knowledge</a:t>
             </a:r>
           </a:p>
           <a:p>
@@ -3574,7 +3638,7 @@
                 </a:solidFill>
                 <a:latin typeface="Calibri"/>
               </a:rPr>
-              <a:t>Chooses not to guess (rule 4)</a:t>
+              <a:t>Calls search_manuals</a:t>
             </a:r>
           </a:p>
         </p:txBody>
@@ -3587,12 +3651,167 @@
         </p:nvSpPr>
         <p:spPr>
           <a:xfrm>
-            <a:off x="8366760" y="1554480"/>
-            <a:ext cx="3429000" cy="2331720"/>
+            <a:off x="6537960" y="1417320"/>
+            <a:ext cx="2148840" cy="2697480"/>
           </a:xfrm>
           <a:prstGeom prst="roundRect">
             <a:avLst>
-              <a:gd name="adj" fmla="val 6000"/>
+              <a:gd name="adj" fmla="val 5000"/>
+            </a:avLst>
+          </a:prstGeom>
+          <a:solidFill>
+            <a:srgbClr val="0B6E4F"/>
+          </a:solidFill>
+          <a:ln>
+            <a:noFill/>
+          </a:ln>
+          <a:effectLst/>
+        </p:spPr>
+        <p:style>
+          <a:lnRef idx="1">
+            <a:schemeClr val="accent1"/>
+          </a:lnRef>
+          <a:fillRef idx="3">
+            <a:schemeClr val="accent1"/>
+          </a:fillRef>
+          <a:effectRef idx="2">
+            <a:schemeClr val="accent1"/>
+          </a:effectRef>
+          <a:fontRef idx="minor">
+            <a:schemeClr val="lt1"/>
+          </a:fontRef>
+        </p:style>
+        <p:txBody>
+          <a:bodyPr rtlCol="0" anchor="t" wrap="square" lIns="146304" rIns="146304" tIns="109728" bIns="109728"/>
+          <a:lstStyle/>
+          <a:p>
+            <a:pPr algn="l">
+              <a:spcAft>
+                <a:spcPts val="500"/>
+              </a:spcAft>
+            </a:pPr>
+            <a:r>
+              <a:rPr sz="1000" b="1" i="0">
+                <a:solidFill>
+                  <a:srgbClr val="E4F2EC"/>
+                </a:solidFill>
+                <a:latin typeface="Calibri"/>
+              </a:rPr>
+              <a:t>TOOLS CALLED — REAL, NOT SIMULATED</a:t>
+            </a:r>
+          </a:p>
+          <a:p>
+            <a:pPr algn="l">
+              <a:spcAft>
+                <a:spcPts val="100"/>
+              </a:spcAft>
+            </a:pPr>
+            <a:r>
+              <a:rPr sz="1050" b="1" i="0">
+                <a:solidFill>
+                  <a:srgbClr val="FFFFFF"/>
+                </a:solidFill>
+                <a:latin typeface="Calibri"/>
+              </a:rPr>
+              <a:t>search_manuals(component</a:t>
+            </a:r>
+          </a:p>
+          <a:p>
+            <a:pPr algn="l">
+              <a:spcAft>
+                <a:spcPts val="400"/>
+              </a:spcAft>
+            </a:pPr>
+            <a:r>
+              <a:rPr sz="1050" b="1" i="0">
+                <a:solidFill>
+                  <a:srgbClr val="FFFFFF"/>
+                </a:solidFill>
+                <a:latin typeface="Calibri"/>
+              </a:rPr>
+              <a:t>replacement + safety checks)</a:t>
+            </a:r>
+          </a:p>
+          <a:p>
+            <a:pPr algn="l">
+              <a:spcAft>
+                <a:spcPts val="100"/>
+              </a:spcAft>
+            </a:pPr>
+            <a:r>
+              <a:rPr sz="1100" b="1" i="0">
+                <a:solidFill>
+                  <a:srgbClr val="FFFFFF"/>
+                </a:solidFill>
+                <a:latin typeface="Calibri"/>
+              </a:rPr>
+              <a:t>→ 5 real excerpts cited</a:t>
+            </a:r>
+          </a:p>
+          <a:p>
+            <a:pPr algn="l">
+              <a:spcAft>
+                <a:spcPts val="100"/>
+              </a:spcAft>
+            </a:pPr>
+            <a:r>
+              <a:rPr sz="950" b="0" i="0">
+                <a:solidFill>
+                  <a:srgbClr val="E4F2EC"/>
+                </a:solidFill>
+                <a:latin typeface="Calibri"/>
+              </a:rPr>
+              <a:t>Siemens G120C List Manual,</a:t>
+            </a:r>
+          </a:p>
+          <a:p>
+            <a:pPr algn="l">
+              <a:spcAft>
+                <a:spcPts val="100"/>
+              </a:spcAft>
+            </a:pPr>
+            <a:r>
+              <a:rPr sz="950" b="0" i="0">
+                <a:solidFill>
+                  <a:srgbClr val="E4F2EC"/>
+                </a:solidFill>
+                <a:latin typeface="Calibri"/>
+              </a:rPr>
+              <a:t>Operating Instructions —</a:t>
+            </a:r>
+          </a:p>
+          <a:p>
+            <a:pPr algn="l">
+              <a:spcAft>
+                <a:spcPts val="0"/>
+              </a:spcAft>
+            </a:pPr>
+            <a:r>
+              <a:rPr sz="950" b="0" i="0">
+                <a:solidFill>
+                  <a:srgbClr val="E4F2EC"/>
+                </a:solidFill>
+                <a:latin typeface="Calibri"/>
+              </a:rPr>
+              <a:t>pages 430, 678, 740, 839, 840</a:t>
+            </a:r>
+          </a:p>
+        </p:txBody>
+      </p:sp>
+      <p:sp>
+        <p:nvSpPr>
+          <p:cNvPr id="9" name="Rounded Rectangle 8"/>
+          <p:cNvSpPr/>
+          <p:nvPr/>
+        </p:nvSpPr>
+        <p:spPr>
+          <a:xfrm>
+            <a:off x="8961120" y="1417320"/>
+            <a:ext cx="2862072" cy="2697480"/>
+          </a:xfrm>
+          <a:prstGeom prst="roundRect">
+            <a:avLst>
+              <a:gd name="adj" fmla="val 5000"/>
             </a:avLst>
           </a:prstGeom>
           <a:solidFill>
@@ -3618,7 +3837,7 @@
           </a:fontRef>
         </p:style>
         <p:txBody>
-          <a:bodyPr rtlCol="0" anchor="t" wrap="square" lIns="164592" rIns="164592" tIns="109728" bIns="109728"/>
+          <a:bodyPr rtlCol="0" anchor="t" wrap="square" lIns="146304" rIns="146304" tIns="109728" bIns="109728"/>
           <a:lstStyle/>
           <a:p>
             <a:pPr algn="l">
@@ -3627,13 +3846,13 @@
               </a:spcAft>
             </a:pPr>
             <a:r>
-              <a:rPr sz="1100" b="1" i="0">
+              <a:rPr sz="1000" b="1" i="0">
                 <a:solidFill>
                   <a:srgbClr val="FBE3C0"/>
                 </a:solidFill>
                 <a:latin typeface="Calibri"/>
               </a:rPr>
-              <a:t>FINAL OUTPUT</a:t>
+              <a:t>FINAL OUTPUT — COMPLETE ANSWER</a:t>
             </a:r>
           </a:p>
           <a:p>
@@ -3643,13 +3862,13 @@
               </a:spcAft>
             </a:pPr>
             <a:r>
-              <a:rPr sz="1200" b="1" i="0">
+              <a:rPr sz="1100" b="1" i="0">
                 <a:solidFill>
                   <a:srgbClr val="FFFFFF"/>
                 </a:solidFill>
                 <a:latin typeface="Calibri"/>
               </a:rPr>
-              <a:t>"Could you please clarify what</a:t>
+              <a:t>Safety precautions first:</a:t>
             </a:r>
           </a:p>
           <a:p>
@@ -3659,13 +3878,13 @@
               </a:spcAft>
             </a:pPr>
             <a:r>
-              <a:rPr sz="1200" b="1" i="0">
-                <a:solidFill>
-                  <a:srgbClr val="FFFFFF"/>
+              <a:rPr sz="950" b="0" i="0">
+                <a:solidFill>
+                  <a:srgbClr val="FBE3C0"/>
                 </a:solidFill>
                 <a:latin typeface="Calibri"/>
               </a:rPr>
-              <a:t>component or part the photo shows</a:t>
+              <a:t>isolate &amp; de-energize, lockout/</a:t>
             </a:r>
           </a:p>
           <a:p>
@@ -3675,29 +3894,77 @@
               </a:spcAft>
             </a:pPr>
             <a:r>
-              <a:rPr sz="1200" b="1" i="0">
-                <a:solidFill>
-                  <a:srgbClr val="FFFFFF"/>
+              <a:rPr sz="950" b="0" i="0">
+                <a:solidFill>
+                  <a:srgbClr val="FBE3C0"/>
                 </a:solidFill>
                 <a:latin typeface="Calibri"/>
               </a:rPr>
-              <a:t>that was analyzed as having</a:t>
+              <a:t>tagout, discharge DC link,</a:t>
             </a:r>
           </a:p>
           <a:p>
             <a:pPr algn="l">
               <a:spcAft>
-                <a:spcPts val="500"/>
+                <a:spcPts val="400"/>
               </a:spcAft>
             </a:pPr>
             <a:r>
-              <a:rPr sz="1200" b="1" i="0">
-                <a:solidFill>
-                  <a:srgbClr val="FFFFFF"/>
+              <a:rPr sz="950" b="0" i="0">
+                <a:solidFill>
+                  <a:srgbClr val="FBE3C0"/>
                 </a:solidFill>
                 <a:latin typeface="Calibri"/>
               </a:rPr>
-              <a:t>structural damage?"</a:t>
+              <a:t>verify no voltage.</a:t>
+            </a:r>
+          </a:p>
+          <a:p>
+            <a:pPr algn="l">
+              <a:spcAft>
+                <a:spcPts val="100"/>
+              </a:spcAft>
+            </a:pPr>
+            <a:r>
+              <a:rPr sz="950" b="0" i="0">
+                <a:solidFill>
+                  <a:srgbClr val="FFFFFF"/>
+                </a:solidFill>
+                <a:latin typeface="Calibri"/>
+              </a:rPr>
+              <a:t>Then: identify component,</a:t>
+            </a:r>
+          </a:p>
+          <a:p>
+            <a:pPr algn="l">
+              <a:spcAft>
+                <a:spcPts val="100"/>
+              </a:spcAft>
+            </a:pPr>
+            <a:r>
+              <a:rPr sz="950" b="0" i="0">
+                <a:solidFill>
+                  <a:srgbClr val="FFFFFF"/>
+                </a:solidFill>
+                <a:latin typeface="Calibri"/>
+              </a:rPr>
+              <a:t>check cable connections,</a:t>
+            </a:r>
+          </a:p>
+          <a:p>
+            <a:pPr algn="l">
+              <a:spcAft>
+                <a:spcPts val="100"/>
+              </a:spcAft>
+            </a:pPr>
+            <a:r>
+              <a:rPr sz="950" b="0" i="0">
+                <a:solidFill>
+                  <a:srgbClr val="FFFFFF"/>
+                </a:solidFill>
+                <a:latin typeface="Calibri"/>
+              </a:rPr>
+              <a:t>update drive parameters</a:t>
             </a:r>
           </a:p>
           <a:p>
@@ -3707,27 +3974,27 @@
               </a:spcAft>
             </a:pPr>
             <a:r>
-              <a:rPr sz="1050" b="0" i="0">
-                <a:solidFill>
-                  <a:srgbClr val="FBE3C0"/>
+              <a:rPr sz="950" b="0" i="0">
+                <a:solidFill>
+                  <a:srgbClr val="FFFFFF"/>
                 </a:solidFill>
                 <a:latin typeface="Calibri"/>
               </a:rPr>
-              <a:t>Tools used: none — asked instead of guessing</a:t>
-            </a:r>
-          </a:p>
-        </p:txBody>
-      </p:sp>
-      <p:sp>
-        <p:nvSpPr>
-          <p:cNvPr id="9" name="Chevron 8"/>
+              <a:t>after replacement — cited.</a:t>
+            </a:r>
+          </a:p>
+        </p:txBody>
+      </p:sp>
+      <p:sp>
+        <p:nvSpPr>
+          <p:cNvPr id="10" name="Chevron 9"/>
           <p:cNvSpPr/>
           <p:nvPr/>
         </p:nvSpPr>
         <p:spPr>
           <a:xfrm>
-            <a:off x="2770632" y="2601468"/>
-            <a:ext cx="173736" cy="237744"/>
+            <a:off x="2176272" y="2647188"/>
+            <a:ext cx="219455" cy="237744"/>
           </a:xfrm>
           <a:prstGeom prst="chevron">
             <a:avLst/>
@@ -3764,14 +4031,14 @@
       </p:sp>
       <p:sp>
         <p:nvSpPr>
-          <p:cNvPr id="10" name="Chevron 9"/>
+          <p:cNvPr id="11" name="Chevron 10"/>
           <p:cNvSpPr/>
           <p:nvPr/>
         </p:nvSpPr>
         <p:spPr>
           <a:xfrm>
-            <a:off x="5330952" y="2601468"/>
-            <a:ext cx="173736" cy="237744"/>
+            <a:off x="4233672" y="2647188"/>
+            <a:ext cx="219456" cy="237744"/>
           </a:xfrm>
           <a:prstGeom prst="chevron">
             <a:avLst/>
@@ -3808,14 +4075,14 @@
       </p:sp>
       <p:sp>
         <p:nvSpPr>
-          <p:cNvPr id="11" name="Chevron 10"/>
+          <p:cNvPr id="12" name="Chevron 11"/>
           <p:cNvSpPr/>
           <p:nvPr/>
         </p:nvSpPr>
         <p:spPr>
           <a:xfrm>
-            <a:off x="8165592" y="2601468"/>
-            <a:ext cx="173736" cy="237744"/>
+            <a:off x="6291072" y="2647188"/>
+            <a:ext cx="219455" cy="237744"/>
           </a:xfrm>
           <a:prstGeom prst="chevron">
             <a:avLst/>
@@ -3852,18 +4119,62 @@
       </p:sp>
       <p:sp>
         <p:nvSpPr>
-          <p:cNvPr id="12" name="Rounded Rectangle 11"/>
+          <p:cNvPr id="13" name="Chevron 12"/>
           <p:cNvSpPr/>
           <p:nvPr/>
         </p:nvSpPr>
         <p:spPr>
           <a:xfrm>
-            <a:off x="411480" y="4251960"/>
-            <a:ext cx="11384280" cy="1417320"/>
+            <a:off x="8714232" y="2647188"/>
+            <a:ext cx="219456" cy="237744"/>
+          </a:xfrm>
+          <a:prstGeom prst="chevron">
+            <a:avLst/>
+          </a:prstGeom>
+          <a:solidFill>
+            <a:srgbClr val="C7CDD3"/>
+          </a:solidFill>
+          <a:ln>
+            <a:noFill/>
+          </a:ln>
+          <a:effectLst/>
+        </p:spPr>
+        <p:style>
+          <a:lnRef idx="1">
+            <a:schemeClr val="accent1"/>
+          </a:lnRef>
+          <a:fillRef idx="3">
+            <a:schemeClr val="accent1"/>
+          </a:fillRef>
+          <a:effectRef idx="2">
+            <a:schemeClr val="accent1"/>
+          </a:effectRef>
+          <a:fontRef idx="minor">
+            <a:schemeClr val="lt1"/>
+          </a:fontRef>
+        </p:style>
+        <p:txBody>
+          <a:bodyPr rtlCol="0" anchor="ctr"/>
+          <a:lstStyle/>
+          <a:p>
+            <a:pPr algn="ctr"/>
+          </a:p>
+        </p:txBody>
+      </p:sp>
+      <p:sp>
+        <p:nvSpPr>
+          <p:cNvPr id="14" name="Rounded Rectangle 13"/>
+          <p:cNvSpPr/>
+          <p:nvPr/>
+        </p:nvSpPr>
+        <p:spPr>
+          <a:xfrm>
+            <a:off x="365760" y="4343400"/>
+            <a:ext cx="11430000" cy="1325880"/>
           </a:xfrm>
           <a:prstGeom prst="roundRect">
             <a:avLst>
-              <a:gd name="adj" fmla="val 6000"/>
+              <a:gd name="adj" fmla="val 5000"/>
             </a:avLst>
           </a:prstGeom>
           <a:solidFill>
@@ -3889,7 +4200,7 @@
           </a:fontRef>
         </p:style>
         <p:txBody>
-          <a:bodyPr rtlCol="0" anchor="t" wrap="square" lIns="256032" rIns="256032" tIns="146304" bIns="146304"/>
+          <a:bodyPr rtlCol="0" anchor="t" wrap="square" lIns="237744" rIns="237744" tIns="128016" bIns="128016"/>
           <a:lstStyle/>
           <a:p>
             <a:pPr algn="l">
@@ -3920,7 +4231,7 @@
                 </a:solidFill>
                 <a:latin typeface="Calibri"/>
               </a:rPr>
-              <a:t>"Tools used: none" is itself the proof — a fixed pipeline always runs the same steps; this agent skipped every tool and asked a question instead, because the two signals genuinely disagreed.</a:t>
+              <a:t>This exact conversation was run live against the deployed app, not hand-written: "Tools used: search_manuals" and the 5 cited pages come straight from that run.</a:t>
             </a:r>
           </a:p>
           <a:p>
@@ -3936,20 +4247,20 @@
                 </a:solidFill>
                 <a:latin typeface="Calibri"/>
               </a:rPr>
-              <a:t>The safety-first rule (rule 6) correctly does NOT add a precautions section here either — there is no physical action to perform yet, only a question.</a:t>
-            </a:r>
-          </a:p>
-        </p:txBody>
-      </p:sp>
-      <p:sp>
-        <p:nvSpPr>
-          <p:cNvPr id="13" name="TextBox 12"/>
+              <a:t>Safety precautions came first because rule 6 requires it whenever a physical action is recommended — confirmed here, not assumed.</a:t>
+            </a:r>
+          </a:p>
+        </p:txBody>
+      </p:sp>
+      <p:sp>
+        <p:nvSpPr>
+          <p:cNvPr id="15" name="TextBox 14"/>
           <p:cNvSpPr txBox="1"/>
           <p:nvPr/>
         </p:nvSpPr>
         <p:spPr>
           <a:xfrm>
-            <a:off x="411480" y="6309360"/>
+            <a:off x="365760" y="6172200"/>
             <a:ext cx="11247120" cy="365760"/>
           </a:xfrm>
           <a:prstGeom prst="rect">

</xml_diff>